<commit_message>
Use the office-lead Telegram and MAX QR codes on the CTA slide
Replaces the interim codes lifted from the partner deck with the two
office-specific ones: Telegram clck.ru/3VfGNJ and MAX clck.ru/3VfGP6. The
second messenger is MAX, not WhatsApp, so the card label changes with it.

Both are recoloured to the brand palette and flipped to standard polarity —
dark modules on a light tile instead of the source files' light-on-dark. The
inverted form only decoded after inversion in testing, which some phone
scanners will not do; the standard form decodes straight off the page and, as
ink on cream, still sits inside the palette. Originals are kept under
src-images/qr/ if the inverted look is preferred.

Co-Authored-By: Claude Opus 5 <noreply@anthropic.com>
Claude-Session: https://claude.ai/code/session_014vkULsLS2HyJV1FtfsGcB2
</commit_message>
<xml_diff>
--- a/presentations/office-client/Продай_за_меня_ОФИСЫ_клиентская.pptx
+++ b/presentations/office-client/Продай_за_меня_ОФИСЫ_клиентская.pptx
@@ -5977,9 +5977,31 @@
           </a:prstGeom>
         </p:spPr>
       </p:pic>
+      <p:sp>
+        <p:nvSpPr>
+          <p:cNvPr id="14" name="Shape 8"/>
+          <p:cNvSpPr/>
+          <p:nvPr/>
+        </p:nvSpPr>
+        <p:spPr>
+          <a:xfrm>
+            <a:off x="6932524" y="3145536"/>
+            <a:ext cx="1682496" cy="1682496"/>
+          </a:xfrm>
+          <a:prstGeom prst="roundRect">
+            <a:avLst>
+              <a:gd name="adj" fmla="val 2717"/>
+            </a:avLst>
+          </a:prstGeom>
+          <a:solidFill>
+            <a:srgbClr val="F7F1E7"/>
+          </a:solidFill>
+          <a:ln/>
+        </p:spPr>
+      </p:sp>
       <p:pic>
         <p:nvPicPr>
-          <p:cNvPr id="14" name="Image 4" descr="/home/user/mysteryslavic-2026-07-19_16-47-00/presentations/office-client/assets/qr-telegram.png">    </p:cNvPr>
+          <p:cNvPr id="15" name="Image 4" descr="/home/user/mysteryslavic-2026-07-19_16-47-00/presentations/office-client/assets/qr-telegram.png">    </p:cNvPr>
           <p:cNvPicPr>
             <a:picLocks noChangeAspect="1"/>
           </p:cNvPicPr>
@@ -6003,7 +6025,7 @@
       </p:pic>
       <p:sp>
         <p:nvSpPr>
-          <p:cNvPr id="15" name="Text 8"/>
+          <p:cNvPr id="16" name="Text 9"/>
           <p:cNvSpPr txBox="1"/>
           <p:nvPr/>
         </p:nvSpPr>
@@ -6042,7 +6064,7 @@
       </p:sp>
       <p:sp>
         <p:nvSpPr>
-          <p:cNvPr id="16" name="Shape 9"/>
+          <p:cNvPr id="17" name="Shape 10"/>
           <p:cNvSpPr/>
           <p:nvPr/>
         </p:nvSpPr>
@@ -6069,7 +6091,7 @@
       </p:sp>
       <p:pic>
         <p:nvPicPr>
-          <p:cNvPr id="17" name="Image 5" descr="/home/user/mysteryslavic-2026-07-19_16-47-00/presentations/office-client/assets/ic-messagecircle.png">    </p:cNvPr>
+          <p:cNvPr id="18" name="Image 5" descr="/home/user/mysteryslavic-2026-07-19_16-47-00/presentations/office-client/assets/ic-messagecircle.png">    </p:cNvPr>
           <p:cNvPicPr>
             <a:picLocks noChangeAspect="1"/>
           </p:cNvPicPr>
@@ -6091,9 +6113,31 @@
           </a:prstGeom>
         </p:spPr>
       </p:pic>
+      <p:sp>
+        <p:nvSpPr>
+          <p:cNvPr id="19" name="Shape 11"/>
+          <p:cNvSpPr/>
+          <p:nvPr/>
+        </p:nvSpPr>
+        <p:spPr>
+          <a:xfrm>
+            <a:off x="9437980" y="3145536"/>
+            <a:ext cx="1682496" cy="1682496"/>
+          </a:xfrm>
+          <a:prstGeom prst="roundRect">
+            <a:avLst>
+              <a:gd name="adj" fmla="val 2717"/>
+            </a:avLst>
+          </a:prstGeom>
+          <a:solidFill>
+            <a:srgbClr val="F7F1E7"/>
+          </a:solidFill>
+          <a:ln/>
+        </p:spPr>
+      </p:sp>
       <p:pic>
         <p:nvPicPr>
-          <p:cNvPr id="18" name="Image 6" descr="/home/user/mysteryslavic-2026-07-19_16-47-00/presentations/office-client/assets/qr-whatsapp.png">    </p:cNvPr>
+          <p:cNvPr id="20" name="Image 6" descr="/home/user/mysteryslavic-2026-07-19_16-47-00/presentations/office-client/assets/qr-max.png">    </p:cNvPr>
           <p:cNvPicPr>
             <a:picLocks noChangeAspect="1"/>
           </p:cNvPicPr>
@@ -6117,7 +6161,7 @@
       </p:pic>
       <p:sp>
         <p:nvSpPr>
-          <p:cNvPr id="19" name="Text 10"/>
+          <p:cNvPr id="21" name="Text 12"/>
           <p:cNvSpPr txBox="1"/>
           <p:nvPr/>
         </p:nvSpPr>
@@ -6148,7 +6192,7 @@
                 <a:ea typeface="Inter" pitchFamily="34" charset="-122"/>
                 <a:cs typeface="Inter" pitchFamily="34" charset="-120"/>
               </a:rPr>
-              <a:t>WHATSAPP</a:t>
+              <a:t>MAX</a:t>
             </a:r>
             <a:endParaRPr lang="en-US" sz="1250" dirty="0"/>
           </a:p>
@@ -6156,7 +6200,7 @@
       </p:sp>
       <p:sp>
         <p:nvSpPr>
-          <p:cNvPr id="20" name="Shape 11"/>
+          <p:cNvPr id="22" name="Shape 13"/>
           <p:cNvSpPr/>
           <p:nvPr/>
         </p:nvSpPr>
@@ -6180,7 +6224,7 @@
       </p:sp>
       <p:sp>
         <p:nvSpPr>
-          <p:cNvPr id="21" name="Text 12"/>
+          <p:cNvPr id="23" name="Text 14"/>
           <p:cNvSpPr txBox="1"/>
           <p:nvPr/>
         </p:nvSpPr>

</xml_diff>